<commit_message>
Add C11 3 kandungan skincare carousel; fix highlight spacing and ghost sizing in PPTX builder
Co-Authored-By: Claude Sonnet 5.5 <noreply@anthropic.com>
Claude-Session: https://claude.ai/code/session_013RWrZY7Vk6d3R8BExQoLnL
</commit_message>
<xml_diff>
--- a/carousel-output/C07-15-menit-vs-gym/C07.pptx
+++ b/carousel-output/C07-15-menit-vs-gym/C07.pptx
@@ -4468,7 +4468,7 @@
         </p:nvSpPr>
         <p:spPr>
           <a:xfrm>
-            <a:off x="2395314" y="6691408"/>
+            <a:off x="2315245" y="6691408"/>
             <a:ext cx="755303" cy="854964"/>
           </a:xfrm>
           <a:prstGeom prst="roundRect">
@@ -4500,7 +4500,7 @@
         </p:nvSpPr>
         <p:spPr>
           <a:xfrm>
-            <a:off x="5749156" y="6691408"/>
+            <a:off x="5829226" y="6691408"/>
             <a:ext cx="2142530" cy="854964"/>
           </a:xfrm>
           <a:prstGeom prst="roundRect">
@@ -4568,7 +4568,7 @@
                 </a:solidFill>
                 <a:latin typeface="Poppins ExtraBold"/>
               </a:rPr>
-              <a:t> &gt;  1 Jam Niat </a:t>
+              <a:t> &gt;  1 Jam  Niat </a:t>
             </a:r>
             <a:br/>
             <a:r>
@@ -5717,7 +5717,7 @@
         </p:nvSpPr>
         <p:spPr>
           <a:xfrm>
-            <a:off x="3447083" y="8804720"/>
+            <a:off x="3501554" y="8804720"/>
             <a:ext cx="2125414" cy="427482"/>
           </a:xfrm>
           <a:prstGeom prst="roundRect">
@@ -5775,7 +5775,7 @@
                 </a:solidFill>
                 <a:latin typeface="Poppins Medium"/>
               </a:rPr>
-              <a:t>Kecil tapi konsisten, lebih baik dari</a:t>
+              <a:t>Kecil tapi  konsisten, lebih baik dari</a:t>
             </a:r>
             <a:br/>
             <a:r>

</xml_diff>